<commit_message>
remove legacy overstock route
</commit_message>
<xml_diff>
--- a/Final/新增 Microsoft PowerPoint 簡報 (5) [自動儲存].pptx
+++ b/Final/新增 Microsoft PowerPoint 簡報 (5) [自動儲存].pptx
@@ -8,10 +8,10 @@
     <p:sldId id="256" r:id="rId2"/>
     <p:sldId id="257" r:id="rId3"/>
     <p:sldId id="258" r:id="rId4"/>
-    <p:sldId id="259" r:id="rId5"/>
-    <p:sldId id="260" r:id="rId6"/>
-    <p:sldId id="261" r:id="rId7"/>
-    <p:sldId id="262" r:id="rId8"/>
+    <p:sldId id="260" r:id="rId5"/>
+    <p:sldId id="261" r:id="rId6"/>
+    <p:sldId id="262" r:id="rId7"/>
+    <p:sldId id="263" r:id="rId8"/>
   </p:sldIdLst>
   <p:sldSz cx="9144000" cy="6858000" type="screen4x3"/>
   <p:notesSz cx="6858000" cy="9144000"/>
@@ -310,7 +310,7 @@
           <a:p>
             <a:fld id="{5BBEAD13-0566-4C6C-97E7-55F17F24B09F}" type="datetimeFigureOut">
               <a:rPr lang="zh-TW" altLang="en-US" smtClean="0"/>
-              <a:t>2026/2/8</a:t>
+              <a:t>2026/2/13</a:t>
             </a:fld>
             <a:endParaRPr lang="zh-TW" altLang="en-US"/>
           </a:p>
@@ -475,7 +475,7 @@
           <a:p>
             <a:fld id="{5BBEAD13-0566-4C6C-97E7-55F17F24B09F}" type="datetimeFigureOut">
               <a:rPr lang="zh-TW" altLang="en-US" smtClean="0"/>
-              <a:t>2026/2/8</a:t>
+              <a:t>2026/2/13</a:t>
             </a:fld>
             <a:endParaRPr lang="zh-TW" altLang="en-US"/>
           </a:p>
@@ -650,7 +650,7 @@
           <a:p>
             <a:fld id="{5BBEAD13-0566-4C6C-97E7-55F17F24B09F}" type="datetimeFigureOut">
               <a:rPr lang="zh-TW" altLang="en-US" smtClean="0"/>
-              <a:t>2026/2/8</a:t>
+              <a:t>2026/2/13</a:t>
             </a:fld>
             <a:endParaRPr lang="zh-TW" altLang="en-US"/>
           </a:p>
@@ -815,7 +815,7 @@
           <a:p>
             <a:fld id="{5BBEAD13-0566-4C6C-97E7-55F17F24B09F}" type="datetimeFigureOut">
               <a:rPr lang="zh-TW" altLang="en-US" smtClean="0"/>
-              <a:t>2026/2/8</a:t>
+              <a:t>2026/2/13</a:t>
             </a:fld>
             <a:endParaRPr lang="zh-TW" altLang="en-US"/>
           </a:p>
@@ -1056,7 +1056,7 @@
           <a:p>
             <a:fld id="{5BBEAD13-0566-4C6C-97E7-55F17F24B09F}" type="datetimeFigureOut">
               <a:rPr lang="zh-TW" altLang="en-US" smtClean="0"/>
-              <a:t>2026/2/8</a:t>
+              <a:t>2026/2/13</a:t>
             </a:fld>
             <a:endParaRPr lang="zh-TW" altLang="en-US"/>
           </a:p>
@@ -1339,7 +1339,7 @@
           <a:p>
             <a:fld id="{5BBEAD13-0566-4C6C-97E7-55F17F24B09F}" type="datetimeFigureOut">
               <a:rPr lang="zh-TW" altLang="en-US" smtClean="0"/>
-              <a:t>2026/2/8</a:t>
+              <a:t>2026/2/13</a:t>
             </a:fld>
             <a:endParaRPr lang="zh-TW" altLang="en-US"/>
           </a:p>
@@ -1756,7 +1756,7 @@
           <a:p>
             <a:fld id="{5BBEAD13-0566-4C6C-97E7-55F17F24B09F}" type="datetimeFigureOut">
               <a:rPr lang="zh-TW" altLang="en-US" smtClean="0"/>
-              <a:t>2026/2/8</a:t>
+              <a:t>2026/2/13</a:t>
             </a:fld>
             <a:endParaRPr lang="zh-TW" altLang="en-US"/>
           </a:p>
@@ -1869,7 +1869,7 @@
           <a:p>
             <a:fld id="{5BBEAD13-0566-4C6C-97E7-55F17F24B09F}" type="datetimeFigureOut">
               <a:rPr lang="zh-TW" altLang="en-US" smtClean="0"/>
-              <a:t>2026/2/8</a:t>
+              <a:t>2026/2/13</a:t>
             </a:fld>
             <a:endParaRPr lang="zh-TW" altLang="en-US"/>
           </a:p>
@@ -1959,7 +1959,7 @@
           <a:p>
             <a:fld id="{5BBEAD13-0566-4C6C-97E7-55F17F24B09F}" type="datetimeFigureOut">
               <a:rPr lang="zh-TW" altLang="en-US" smtClean="0"/>
-              <a:t>2026/2/8</a:t>
+              <a:t>2026/2/13</a:t>
             </a:fld>
             <a:endParaRPr lang="zh-TW" altLang="en-US"/>
           </a:p>
@@ -2231,7 +2231,7 @@
           <a:p>
             <a:fld id="{5BBEAD13-0566-4C6C-97E7-55F17F24B09F}" type="datetimeFigureOut">
               <a:rPr lang="zh-TW" altLang="en-US" smtClean="0"/>
-              <a:t>2026/2/8</a:t>
+              <a:t>2026/2/13</a:t>
             </a:fld>
             <a:endParaRPr lang="zh-TW" altLang="en-US"/>
           </a:p>
@@ -2479,7 +2479,7 @@
           <a:p>
             <a:fld id="{5BBEAD13-0566-4C6C-97E7-55F17F24B09F}" type="datetimeFigureOut">
               <a:rPr lang="zh-TW" altLang="en-US" smtClean="0"/>
-              <a:t>2026/2/8</a:t>
+              <a:t>2026/2/13</a:t>
             </a:fld>
             <a:endParaRPr lang="zh-TW" altLang="en-US"/>
           </a:p>
@@ -2687,7 +2687,7 @@
           <a:p>
             <a:fld id="{5BBEAD13-0566-4C6C-97E7-55F17F24B09F}" type="datetimeFigureOut">
               <a:rPr lang="zh-TW" altLang="en-US" smtClean="0"/>
-              <a:t>2026/2/8</a:t>
+              <a:t>2026/2/13</a:t>
             </a:fld>
             <a:endParaRPr lang="zh-TW" altLang="en-US"/>
           </a:p>
@@ -3059,7 +3059,7 @@
       </p:grpSpPr>
       <p:pic>
         <p:nvPicPr>
-          <p:cNvPr id="9" name="圖片 8"/>
+          <p:cNvPr id="42" name="圖片 41"/>
           <p:cNvPicPr>
             <a:picLocks noChangeAspect="1"/>
           </p:cNvPicPr>
@@ -3079,6 +3079,36 @@
         </p:blipFill>
         <p:spPr>
           <a:xfrm>
+            <a:off x="2943122" y="5151267"/>
+            <a:ext cx="1109280" cy="724428"/>
+          </a:xfrm>
+          <a:prstGeom prst="rect">
+            <a:avLst/>
+          </a:prstGeom>
+        </p:spPr>
+      </p:pic>
+      <p:pic>
+        <p:nvPicPr>
+          <p:cNvPr id="9" name="圖片 8"/>
+          <p:cNvPicPr>
+            <a:picLocks noChangeAspect="1"/>
+          </p:cNvPicPr>
+          <p:nvPr/>
+        </p:nvPicPr>
+        <p:blipFill>
+          <a:blip r:embed="rId3">
+            <a:extLst>
+              <a:ext uri="{28A0092B-C50C-407E-A947-70E740481C1C}">
+                <a14:useLocalDpi xmlns:a14="http://schemas.microsoft.com/office/drawing/2010/main" val="0"/>
+              </a:ext>
+            </a:extLst>
+          </a:blip>
+          <a:stretch>
+            <a:fillRect/>
+          </a:stretch>
+        </p:blipFill>
+        <p:spPr>
+          <a:xfrm>
             <a:off x="357865" y="1089865"/>
             <a:ext cx="2491256" cy="4905858"/>
           </a:xfrm>
@@ -3159,8 +3189,8 @@
         </p:nvCxnSpPr>
         <p:spPr>
           <a:xfrm flipV="1">
-            <a:off x="1515339" y="966845"/>
-            <a:ext cx="2160239" cy="378112"/>
+            <a:off x="1515339" y="743505"/>
+            <a:ext cx="1183365" cy="601453"/>
           </a:xfrm>
           <a:prstGeom prst="bentConnector3">
             <a:avLst/>
@@ -3303,11 +3333,11 @@
         <p:spPr>
           <a:xfrm>
             <a:off x="1732240" y="3317771"/>
-            <a:ext cx="2877489" cy="1007685"/>
+            <a:ext cx="2901932" cy="1665226"/>
           </a:xfrm>
           <a:prstGeom prst="bentConnector3">
             <a:avLst>
-              <a:gd name="adj1" fmla="val 26545"/>
+              <a:gd name="adj1" fmla="val 31994"/>
             </a:avLst>
           </a:prstGeom>
           <a:ln>
@@ -3378,7 +3408,7 @@
         <p:spPr>
           <a:xfrm>
             <a:off x="1551037" y="2924944"/>
-            <a:ext cx="1103625" cy="0"/>
+            <a:ext cx="1248484" cy="0"/>
           </a:xfrm>
           <a:prstGeom prst="straightConnector1">
             <a:avLst/>
@@ -3414,36 +3444,6 @@
           <p:nvPr/>
         </p:nvPicPr>
         <p:blipFill>
-          <a:blip r:embed="rId3">
-            <a:extLst>
-              <a:ext uri="{28A0092B-C50C-407E-A947-70E740481C1C}">
-                <a14:useLocalDpi xmlns:a14="http://schemas.microsoft.com/office/drawing/2010/main" val="0"/>
-              </a:ext>
-            </a:extLst>
-          </a:blip>
-          <a:stretch>
-            <a:fillRect/>
-          </a:stretch>
-        </p:blipFill>
-        <p:spPr>
-          <a:xfrm>
-            <a:off x="3713249" y="239624"/>
-            <a:ext cx="1502825" cy="1059886"/>
-          </a:xfrm>
-          <a:prstGeom prst="rect">
-            <a:avLst/>
-          </a:prstGeom>
-        </p:spPr>
-      </p:pic>
-      <p:pic>
-        <p:nvPicPr>
-          <p:cNvPr id="21" name="圖片 20"/>
-          <p:cNvPicPr>
-            <a:picLocks noChangeAspect="1"/>
-          </p:cNvPicPr>
-          <p:nvPr/>
-        </p:nvPicPr>
-        <p:blipFill>
           <a:blip r:embed="rId4">
             <a:extLst>
               <a:ext uri="{28A0092B-C50C-407E-A947-70E740481C1C}">
@@ -3457,8 +3457,38 @@
         </p:blipFill>
         <p:spPr>
           <a:xfrm>
-            <a:off x="2654662" y="1299510"/>
-            <a:ext cx="1577463" cy="960818"/>
+            <a:off x="2659860" y="193443"/>
+            <a:ext cx="1253060" cy="883736"/>
+          </a:xfrm>
+          <a:prstGeom prst="rect">
+            <a:avLst/>
+          </a:prstGeom>
+        </p:spPr>
+      </p:pic>
+      <p:pic>
+        <p:nvPicPr>
+          <p:cNvPr id="21" name="圖片 20"/>
+          <p:cNvPicPr>
+            <a:picLocks noChangeAspect="1"/>
+          </p:cNvPicPr>
+          <p:nvPr/>
+        </p:nvPicPr>
+        <p:blipFill>
+          <a:blip r:embed="rId5">
+            <a:extLst>
+              <a:ext uri="{28A0092B-C50C-407E-A947-70E740481C1C}">
+                <a14:useLocalDpi xmlns:a14="http://schemas.microsoft.com/office/drawing/2010/main" val="0"/>
+              </a:ext>
+            </a:extLst>
+          </a:blip>
+          <a:stretch>
+            <a:fillRect/>
+          </a:stretch>
+        </p:blipFill>
+        <p:spPr>
+          <a:xfrm>
+            <a:off x="2610957" y="1213400"/>
+            <a:ext cx="1443608" cy="879288"/>
           </a:xfrm>
           <a:prstGeom prst="rect">
             <a:avLst/>
@@ -3473,12 +3503,12 @@
         </p:nvCxnSpPr>
         <p:spPr>
           <a:xfrm flipV="1">
-            <a:off x="2610957" y="1527603"/>
-            <a:ext cx="4049275" cy="956328"/>
+            <a:off x="2610957" y="781779"/>
+            <a:ext cx="4125141" cy="1702152"/>
           </a:xfrm>
           <a:prstGeom prst="bentConnector3">
             <a:avLst>
-              <a:gd name="adj1" fmla="val 45161"/>
+              <a:gd name="adj1" fmla="val 36806"/>
             </a:avLst>
           </a:prstGeom>
           <a:ln>
@@ -3506,18 +3536,18 @@
       <p:cxnSp>
         <p:nvCxnSpPr>
           <p:cNvPr id="41" name="肘形接點 40"/>
-          <p:cNvCxnSpPr>
-            <a:endCxn id="42" idx="1"/>
-          </p:cNvCxnSpPr>
+          <p:cNvCxnSpPr/>
           <p:nvPr/>
         </p:nvCxnSpPr>
         <p:spPr>
           <a:xfrm>
-            <a:off x="1347138" y="3772930"/>
-            <a:ext cx="1271010" cy="1205152"/>
+            <a:off x="1259632" y="3757201"/>
+            <a:ext cx="1692734" cy="1603388"/>
           </a:xfrm>
           <a:prstGeom prst="bentConnector3">
-            <a:avLst/>
+            <a:avLst>
+              <a:gd name="adj1" fmla="val 63505"/>
+            </a:avLst>
           </a:prstGeom>
           <a:ln>
             <a:solidFill>
@@ -3543,37 +3573,7 @@
       </p:cxnSp>
       <p:pic>
         <p:nvPicPr>
-          <p:cNvPr id="42" name="圖片 41"/>
-          <p:cNvPicPr>
-            <a:picLocks noChangeAspect="1"/>
-          </p:cNvPicPr>
-          <p:nvPr/>
-        </p:nvPicPr>
-        <p:blipFill>
-          <a:blip r:embed="rId5">
-            <a:extLst>
-              <a:ext uri="{28A0092B-C50C-407E-A947-70E740481C1C}">
-                <a14:useLocalDpi xmlns:a14="http://schemas.microsoft.com/office/drawing/2010/main" val="0"/>
-              </a:ext>
-            </a:extLst>
-          </a:blip>
-          <a:stretch>
-            <a:fillRect/>
-          </a:stretch>
-        </p:blipFill>
-        <p:spPr>
-          <a:xfrm>
-            <a:off x="2618148" y="4498035"/>
-            <a:ext cx="1470143" cy="960094"/>
-          </a:xfrm>
-          <a:prstGeom prst="rect">
-            <a:avLst/>
-          </a:prstGeom>
-        </p:spPr>
-      </p:pic>
-      <p:pic>
-        <p:nvPicPr>
-          <p:cNvPr id="2" name="圖片 1"/>
+          <p:cNvPr id="13" name="圖片 12"/>
           <p:cNvPicPr>
             <a:picLocks noChangeAspect="1"/>
           </p:cNvPicPr>
@@ -3593,8 +3593,8 @@
         </p:blipFill>
         <p:spPr>
           <a:xfrm>
-            <a:off x="2698704" y="2545244"/>
-            <a:ext cx="1524792" cy="1696458"/>
+            <a:off x="6823845" y="178365"/>
+            <a:ext cx="2174064" cy="3518412"/>
           </a:xfrm>
           <a:prstGeom prst="rect">
             <a:avLst/>
@@ -3603,7 +3603,7 @@
       </p:pic>
       <p:pic>
         <p:nvPicPr>
-          <p:cNvPr id="10" name="圖片 9"/>
+          <p:cNvPr id="17" name="圖片 16"/>
           <p:cNvPicPr>
             <a:picLocks noChangeAspect="1"/>
           </p:cNvPicPr>
@@ -3623,8 +3623,8 @@
         </p:blipFill>
         <p:spPr>
           <a:xfrm>
-            <a:off x="4645762" y="1964695"/>
-            <a:ext cx="1839455" cy="4465729"/>
+            <a:off x="4737417" y="1077179"/>
+            <a:ext cx="1935860" cy="5225703"/>
           </a:xfrm>
           <a:prstGeom prst="rect">
             <a:avLst/>
@@ -3633,7 +3633,7 @@
       </p:pic>
       <p:pic>
         <p:nvPicPr>
-          <p:cNvPr id="11" name="圖片 10"/>
+          <p:cNvPr id="31" name="圖片 30"/>
           <p:cNvPicPr>
             <a:picLocks noChangeAspect="1"/>
           </p:cNvPicPr>
@@ -3653,8 +3653,104 @@
         </p:blipFill>
         <p:spPr>
           <a:xfrm>
-            <a:off x="6740788" y="429733"/>
-            <a:ext cx="2209716" cy="3343197"/>
+            <a:off x="2799520" y="2564974"/>
+            <a:ext cx="1781891" cy="2413447"/>
+          </a:xfrm>
+          <a:prstGeom prst="rect">
+            <a:avLst/>
+          </a:prstGeom>
+        </p:spPr>
+      </p:pic>
+      <p:pic>
+        <p:nvPicPr>
+          <p:cNvPr id="33" name="圖片 32"/>
+          <p:cNvPicPr>
+            <a:picLocks noChangeAspect="1"/>
+          </p:cNvPicPr>
+          <p:nvPr/>
+        </p:nvPicPr>
+        <p:blipFill>
+          <a:blip r:embed="rId9">
+            <a:extLst>
+              <a:ext uri="{28A0092B-C50C-407E-A947-70E740481C1C}">
+                <a14:useLocalDpi xmlns:a14="http://schemas.microsoft.com/office/drawing/2010/main" val="0"/>
+              </a:ext>
+            </a:extLst>
+          </a:blip>
+          <a:stretch>
+            <a:fillRect/>
+          </a:stretch>
+        </p:blipFill>
+        <p:spPr>
+          <a:xfrm>
+            <a:off x="357151" y="5921935"/>
+            <a:ext cx="1940677" cy="411659"/>
+          </a:xfrm>
+          <a:prstGeom prst="rect">
+            <a:avLst/>
+          </a:prstGeom>
+        </p:spPr>
+      </p:pic>
+      <p:cxnSp>
+        <p:nvCxnSpPr>
+          <p:cNvPr id="37" name="直線單箭頭接點 36"/>
+          <p:cNvCxnSpPr/>
+          <p:nvPr/>
+        </p:nvCxnSpPr>
+        <p:spPr>
+          <a:xfrm>
+            <a:off x="2223457" y="6160747"/>
+            <a:ext cx="576064" cy="0"/>
+          </a:xfrm>
+          <a:prstGeom prst="straightConnector1">
+            <a:avLst/>
+          </a:prstGeom>
+          <a:ln>
+            <a:solidFill>
+              <a:srgbClr val="FF0000"/>
+            </a:solidFill>
+            <a:tailEnd type="triangle"/>
+          </a:ln>
+        </p:spPr>
+        <p:style>
+          <a:lnRef idx="1">
+            <a:schemeClr val="accent1"/>
+          </a:lnRef>
+          <a:fillRef idx="0">
+            <a:schemeClr val="accent1"/>
+          </a:fillRef>
+          <a:effectRef idx="0">
+            <a:schemeClr val="accent1"/>
+          </a:effectRef>
+          <a:fontRef idx="minor">
+            <a:schemeClr val="tx1"/>
+          </a:fontRef>
+        </p:style>
+      </p:cxnSp>
+      <p:pic>
+        <p:nvPicPr>
+          <p:cNvPr id="35" name="圖片 34"/>
+          <p:cNvPicPr>
+            <a:picLocks noChangeAspect="1"/>
+          </p:cNvPicPr>
+          <p:nvPr/>
+        </p:nvPicPr>
+        <p:blipFill>
+          <a:blip r:embed="rId10">
+            <a:extLst>
+              <a:ext uri="{28A0092B-C50C-407E-A947-70E740481C1C}">
+                <a14:useLocalDpi xmlns:a14="http://schemas.microsoft.com/office/drawing/2010/main" val="0"/>
+              </a:ext>
+            </a:extLst>
+          </a:blip>
+          <a:stretch>
+            <a:fillRect/>
+          </a:stretch>
+        </p:blipFill>
+        <p:spPr>
+          <a:xfrm>
+            <a:off x="2853354" y="6002398"/>
+            <a:ext cx="1332770" cy="316697"/>
           </a:xfrm>
           <a:prstGeom prst="rect">
             <a:avLst/>
@@ -3812,904 +3908,6 @@
           </p:cNvPicPr>
           <p:nvPr/>
         </p:nvPicPr>
-        <p:blipFill>
-          <a:blip r:embed="rId2">
-            <a:extLst>
-              <a:ext uri="{28A0092B-C50C-407E-A947-70E740481C1C}">
-                <a14:useLocalDpi xmlns:a14="http://schemas.microsoft.com/office/drawing/2010/main" val="0"/>
-              </a:ext>
-            </a:extLst>
-          </a:blip>
-          <a:stretch>
-            <a:fillRect/>
-          </a:stretch>
-        </p:blipFill>
-        <p:spPr>
-          <a:xfrm>
-            <a:off x="120920" y="1282193"/>
-            <a:ext cx="2106807" cy="3312368"/>
-          </a:xfrm>
-          <a:prstGeom prst="rect">
-            <a:avLst/>
-          </a:prstGeom>
-        </p:spPr>
-      </p:pic>
-      <p:sp>
-        <p:nvSpPr>
-          <p:cNvPr id="5" name="文字方塊 4"/>
-          <p:cNvSpPr txBox="1"/>
-          <p:nvPr/>
-        </p:nvSpPr>
-        <p:spPr>
-          <a:xfrm>
-            <a:off x="407177" y="116632"/>
-            <a:ext cx="2880917" cy="369332"/>
-          </a:xfrm>
-          <a:prstGeom prst="rect">
-            <a:avLst/>
-          </a:prstGeom>
-          <a:solidFill>
-            <a:srgbClr val="FFFF00"/>
-          </a:solidFill>
-        </p:spPr>
-        <p:txBody>
-          <a:bodyPr wrap="none" rtlCol="0">
-            <a:spAutoFit/>
-          </a:bodyPr>
-          <a:lstStyle/>
-          <a:p>
-            <a:r>
-              <a:rPr lang="zh-TW" altLang="en-US" b="1" dirty="0" smtClean="0">
-                <a:solidFill>
-                  <a:srgbClr val="FF0000"/>
-                </a:solidFill>
-              </a:rPr>
-              <a:t>本機 </a:t>
-            </a:r>
-            <a:r>
-              <a:rPr lang="en-US" altLang="zh-TW" b="1" dirty="0" err="1" smtClean="0">
-                <a:solidFill>
-                  <a:srgbClr val="FF0000"/>
-                </a:solidFill>
-              </a:rPr>
-              <a:t>Phonmain</a:t>
-            </a:r>
-            <a:r>
-              <a:rPr lang="en-US" altLang="zh-TW" b="1" dirty="0" smtClean="0">
-                <a:solidFill>
-                  <a:srgbClr val="FF0000"/>
-                </a:solidFill>
-              </a:rPr>
-              <a:t> </a:t>
-            </a:r>
-            <a:r>
-              <a:rPr lang="zh-TW" altLang="en-US" b="1" dirty="0" smtClean="0">
-                <a:solidFill>
-                  <a:srgbClr val="FF0000"/>
-                </a:solidFill>
-              </a:rPr>
-              <a:t>根目錄架構</a:t>
-            </a:r>
-            <a:endParaRPr lang="zh-TW" altLang="en-US" b="1" dirty="0">
-              <a:solidFill>
-                <a:srgbClr val="FF0000"/>
-              </a:solidFill>
-            </a:endParaRPr>
-          </a:p>
-        </p:txBody>
-      </p:sp>
-      <p:pic>
-        <p:nvPicPr>
-          <p:cNvPr id="6" name="圖片 5"/>
-          <p:cNvPicPr>
-            <a:picLocks noChangeAspect="1"/>
-          </p:cNvPicPr>
-          <p:nvPr/>
-        </p:nvPicPr>
-        <p:blipFill>
-          <a:blip r:embed="rId3">
-            <a:extLst>
-              <a:ext uri="{28A0092B-C50C-407E-A947-70E740481C1C}">
-                <a14:useLocalDpi xmlns:a14="http://schemas.microsoft.com/office/drawing/2010/main" val="0"/>
-              </a:ext>
-            </a:extLst>
-          </a:blip>
-          <a:stretch>
-            <a:fillRect/>
-          </a:stretch>
-        </p:blipFill>
-        <p:spPr>
-          <a:xfrm>
-            <a:off x="3668749" y="686021"/>
-            <a:ext cx="1186719" cy="539417"/>
-          </a:xfrm>
-          <a:prstGeom prst="rect">
-            <a:avLst/>
-          </a:prstGeom>
-        </p:spPr>
-      </p:pic>
-      <p:cxnSp>
-        <p:nvCxnSpPr>
-          <p:cNvPr id="8" name="肘形接點 7"/>
-          <p:cNvCxnSpPr>
-            <a:endCxn id="6" idx="1"/>
-          </p:cNvCxnSpPr>
-          <p:nvPr/>
-        </p:nvCxnSpPr>
-        <p:spPr>
-          <a:xfrm flipV="1">
-            <a:off x="971600" y="955730"/>
-            <a:ext cx="2697149" cy="730939"/>
-          </a:xfrm>
-          <a:prstGeom prst="bentConnector3">
-            <a:avLst/>
-          </a:prstGeom>
-          <a:ln>
-            <a:headEnd type="none" w="med" len="med"/>
-            <a:tailEnd type="triangle" w="med" len="med"/>
-          </a:ln>
-        </p:spPr>
-        <p:style>
-          <a:lnRef idx="1">
-            <a:schemeClr val="accent1"/>
-          </a:lnRef>
-          <a:fillRef idx="0">
-            <a:schemeClr val="accent1"/>
-          </a:fillRef>
-          <a:effectRef idx="0">
-            <a:schemeClr val="accent1"/>
-          </a:effectRef>
-          <a:fontRef idx="minor">
-            <a:schemeClr val="tx1"/>
-          </a:fontRef>
-        </p:style>
-      </p:cxnSp>
-      <p:cxnSp>
-        <p:nvCxnSpPr>
-          <p:cNvPr id="18" name="直線單箭頭接點 17"/>
-          <p:cNvCxnSpPr/>
-          <p:nvPr/>
-        </p:nvCxnSpPr>
-        <p:spPr>
-          <a:xfrm>
-            <a:off x="971599" y="2689285"/>
-            <a:ext cx="2304000" cy="0"/>
-          </a:xfrm>
-          <a:prstGeom prst="straightConnector1">
-            <a:avLst/>
-          </a:prstGeom>
-          <a:ln>
-            <a:tailEnd type="triangle"/>
-          </a:ln>
-        </p:spPr>
-        <p:style>
-          <a:lnRef idx="1">
-            <a:schemeClr val="accent1"/>
-          </a:lnRef>
-          <a:fillRef idx="0">
-            <a:schemeClr val="accent1"/>
-          </a:fillRef>
-          <a:effectRef idx="0">
-            <a:schemeClr val="accent1"/>
-          </a:effectRef>
-          <a:fontRef idx="minor">
-            <a:schemeClr val="tx1"/>
-          </a:fontRef>
-        </p:style>
-      </p:cxnSp>
-      <p:cxnSp>
-        <p:nvCxnSpPr>
-          <p:cNvPr id="28" name="肘形接點 27"/>
-          <p:cNvCxnSpPr>
-            <a:endCxn id="29" idx="1"/>
-          </p:cNvCxnSpPr>
-          <p:nvPr/>
-        </p:nvCxnSpPr>
-        <p:spPr>
-          <a:xfrm>
-            <a:off x="1170661" y="2938377"/>
-            <a:ext cx="4455738" cy="1534730"/>
-          </a:xfrm>
-          <a:prstGeom prst="bentConnector3">
-            <a:avLst>
-              <a:gd name="adj1" fmla="val 42671"/>
-            </a:avLst>
-          </a:prstGeom>
-          <a:ln>
-            <a:headEnd type="none" w="med" len="med"/>
-            <a:tailEnd type="triangle" w="med" len="med"/>
-          </a:ln>
-        </p:spPr>
-        <p:style>
-          <a:lnRef idx="1">
-            <a:schemeClr val="accent1"/>
-          </a:lnRef>
-          <a:fillRef idx="0">
-            <a:schemeClr val="accent1"/>
-          </a:fillRef>
-          <a:effectRef idx="0">
-            <a:schemeClr val="accent1"/>
-          </a:effectRef>
-          <a:fontRef idx="minor">
-            <a:schemeClr val="tx1"/>
-          </a:fontRef>
-        </p:style>
-      </p:cxnSp>
-      <p:pic>
-        <p:nvPicPr>
-          <p:cNvPr id="30" name="圖片 29"/>
-          <p:cNvPicPr>
-            <a:picLocks noChangeAspect="1"/>
-          </p:cNvPicPr>
-          <p:nvPr/>
-        </p:nvPicPr>
-        <p:blipFill>
-          <a:blip r:embed="rId4">
-            <a:extLst>
-              <a:ext uri="{28A0092B-C50C-407E-A947-70E740481C1C}">
-                <a14:useLocalDpi xmlns:a14="http://schemas.microsoft.com/office/drawing/2010/main" val="0"/>
-              </a:ext>
-            </a:extLst>
-          </a:blip>
-          <a:stretch>
-            <a:fillRect/>
-          </a:stretch>
-        </p:blipFill>
-        <p:spPr>
-          <a:xfrm>
-            <a:off x="1721071" y="3201877"/>
-            <a:ext cx="1128567" cy="759613"/>
-          </a:xfrm>
-          <a:prstGeom prst="rect">
-            <a:avLst/>
-          </a:prstGeom>
-        </p:spPr>
-      </p:pic>
-      <p:cxnSp>
-        <p:nvCxnSpPr>
-          <p:cNvPr id="32" name="肘形接點 31"/>
-          <p:cNvCxnSpPr/>
-          <p:nvPr/>
-        </p:nvCxnSpPr>
-        <p:spPr>
-          <a:xfrm>
-            <a:off x="804040" y="3143379"/>
-            <a:ext cx="991949" cy="451444"/>
-          </a:xfrm>
-          <a:prstGeom prst="bentConnector3">
-            <a:avLst/>
-          </a:prstGeom>
-          <a:ln>
-            <a:headEnd type="none" w="med" len="med"/>
-            <a:tailEnd type="triangle" w="med" len="med"/>
-          </a:ln>
-        </p:spPr>
-        <p:style>
-          <a:lnRef idx="1">
-            <a:schemeClr val="accent1"/>
-          </a:lnRef>
-          <a:fillRef idx="0">
-            <a:schemeClr val="accent1"/>
-          </a:fillRef>
-          <a:effectRef idx="0">
-            <a:schemeClr val="accent1"/>
-          </a:effectRef>
-          <a:fontRef idx="minor">
-            <a:schemeClr val="tx1"/>
-          </a:fontRef>
-        </p:style>
-      </p:cxnSp>
-      <p:cxnSp>
-        <p:nvCxnSpPr>
-          <p:cNvPr id="34" name="直線單箭頭接點 33"/>
-          <p:cNvCxnSpPr/>
-          <p:nvPr/>
-        </p:nvCxnSpPr>
-        <p:spPr>
-          <a:xfrm>
-            <a:off x="1170661" y="589400"/>
-            <a:ext cx="1421" cy="572254"/>
-          </a:xfrm>
-          <a:prstGeom prst="straightConnector1">
-            <a:avLst/>
-          </a:prstGeom>
-          <a:ln>
-            <a:solidFill>
-              <a:srgbClr val="FF0000"/>
-            </a:solidFill>
-            <a:tailEnd type="triangle"/>
-          </a:ln>
-        </p:spPr>
-        <p:style>
-          <a:lnRef idx="1">
-            <a:schemeClr val="accent1"/>
-          </a:lnRef>
-          <a:fillRef idx="0">
-            <a:schemeClr val="accent1"/>
-          </a:fillRef>
-          <a:effectRef idx="0">
-            <a:schemeClr val="accent1"/>
-          </a:effectRef>
-          <a:fontRef idx="minor">
-            <a:schemeClr val="tx1"/>
-          </a:fontRef>
-        </p:style>
-      </p:cxnSp>
-      <p:sp>
-        <p:nvSpPr>
-          <p:cNvPr id="7" name="矩形 6"/>
-          <p:cNvSpPr/>
-          <p:nvPr/>
-        </p:nvSpPr>
-        <p:spPr>
-          <a:xfrm>
-            <a:off x="207793" y="2029848"/>
-            <a:ext cx="1953164" cy="266169"/>
-          </a:xfrm>
-          <a:prstGeom prst="rect">
-            <a:avLst/>
-          </a:prstGeom>
-          <a:solidFill>
-            <a:schemeClr val="bg1"/>
-          </a:solidFill>
-          <a:ln>
-            <a:solidFill>
-              <a:schemeClr val="bg1"/>
-            </a:solidFill>
-          </a:ln>
-        </p:spPr>
-        <p:style>
-          <a:lnRef idx="2">
-            <a:schemeClr val="accent1">
-              <a:shade val="50000"/>
-            </a:schemeClr>
-          </a:lnRef>
-          <a:fillRef idx="1">
-            <a:schemeClr val="accent1"/>
-          </a:fillRef>
-          <a:effectRef idx="0">
-            <a:schemeClr val="accent1"/>
-          </a:effectRef>
-          <a:fontRef idx="minor">
-            <a:schemeClr val="lt1"/>
-          </a:fontRef>
-        </p:style>
-        <p:txBody>
-          <a:bodyPr rtlCol="0" anchor="ctr"/>
-          <a:lstStyle/>
-          <a:p>
-            <a:pPr algn="ctr"/>
-            <a:endParaRPr lang="zh-TW" altLang="en-US"/>
-          </a:p>
-        </p:txBody>
-      </p:sp>
-      <p:pic>
-        <p:nvPicPr>
-          <p:cNvPr id="12" name="圖片 11"/>
-          <p:cNvPicPr>
-            <a:picLocks noChangeAspect="1"/>
-          </p:cNvPicPr>
-          <p:nvPr/>
-        </p:nvPicPr>
-        <p:blipFill>
-          <a:blip r:embed="rId5">
-            <a:extLst>
-              <a:ext uri="{28A0092B-C50C-407E-A947-70E740481C1C}">
-                <a14:useLocalDpi xmlns:a14="http://schemas.microsoft.com/office/drawing/2010/main" val="0"/>
-              </a:ext>
-            </a:extLst>
-          </a:blip>
-          <a:stretch>
-            <a:fillRect/>
-          </a:stretch>
-        </p:blipFill>
-        <p:spPr>
-          <a:xfrm>
-            <a:off x="3277468" y="1960545"/>
-            <a:ext cx="1369100" cy="1113009"/>
-          </a:xfrm>
-          <a:prstGeom prst="rect">
-            <a:avLst/>
-          </a:prstGeom>
-        </p:spPr>
-      </p:pic>
-      <p:pic>
-        <p:nvPicPr>
-          <p:cNvPr id="11" name="圖片 10"/>
-          <p:cNvPicPr>
-            <a:picLocks noChangeAspect="1"/>
-          </p:cNvPicPr>
-          <p:nvPr/>
-        </p:nvPicPr>
-        <p:blipFill>
-          <a:blip r:embed="rId6">
-            <a:extLst>
-              <a:ext uri="{28A0092B-C50C-407E-A947-70E740481C1C}">
-                <a14:useLocalDpi xmlns:a14="http://schemas.microsoft.com/office/drawing/2010/main" val="0"/>
-              </a:ext>
-            </a:extLst>
-          </a:blip>
-          <a:stretch>
-            <a:fillRect/>
-          </a:stretch>
-        </p:blipFill>
-        <p:spPr>
-          <a:xfrm>
-            <a:off x="2791227" y="1210090"/>
-            <a:ext cx="1140649" cy="694759"/>
-          </a:xfrm>
-          <a:prstGeom prst="rect">
-            <a:avLst/>
-          </a:prstGeom>
-        </p:spPr>
-      </p:pic>
-      <p:cxnSp>
-        <p:nvCxnSpPr>
-          <p:cNvPr id="20" name="肘形接點 19"/>
-          <p:cNvCxnSpPr/>
-          <p:nvPr/>
-        </p:nvCxnSpPr>
-        <p:spPr>
-          <a:xfrm flipV="1">
-            <a:off x="827584" y="1582886"/>
-            <a:ext cx="1963643" cy="347379"/>
-          </a:xfrm>
-          <a:prstGeom prst="bentConnector3">
-            <a:avLst>
-              <a:gd name="adj1" fmla="val 84371"/>
-            </a:avLst>
-          </a:prstGeom>
-          <a:ln>
-            <a:tailEnd type="triangle"/>
-          </a:ln>
-        </p:spPr>
-        <p:style>
-          <a:lnRef idx="1">
-            <a:schemeClr val="accent1"/>
-          </a:lnRef>
-          <a:fillRef idx="0">
-            <a:schemeClr val="accent1"/>
-          </a:fillRef>
-          <a:effectRef idx="0">
-            <a:schemeClr val="accent1"/>
-          </a:effectRef>
-          <a:fontRef idx="minor">
-            <a:schemeClr val="tx1"/>
-          </a:fontRef>
-        </p:style>
-      </p:cxnSp>
-      <p:cxnSp>
-        <p:nvCxnSpPr>
-          <p:cNvPr id="24" name="肘形接點 23"/>
-          <p:cNvCxnSpPr/>
-          <p:nvPr/>
-        </p:nvCxnSpPr>
-        <p:spPr>
-          <a:xfrm flipV="1">
-            <a:off x="3668749" y="1567333"/>
-            <a:ext cx="2190848" cy="523682"/>
-          </a:xfrm>
-          <a:prstGeom prst="bentConnector3">
-            <a:avLst>
-              <a:gd name="adj1" fmla="val 50000"/>
-            </a:avLst>
-          </a:prstGeom>
-          <a:ln>
-            <a:headEnd type="none" w="med" len="med"/>
-            <a:tailEnd type="triangle" w="med" len="med"/>
-          </a:ln>
-        </p:spPr>
-        <p:style>
-          <a:lnRef idx="1">
-            <a:schemeClr val="accent1"/>
-          </a:lnRef>
-          <a:fillRef idx="0">
-            <a:schemeClr val="accent1"/>
-          </a:fillRef>
-          <a:effectRef idx="0">
-            <a:schemeClr val="accent1"/>
-          </a:effectRef>
-          <a:fontRef idx="minor">
-            <a:schemeClr val="tx1"/>
-          </a:fontRef>
-        </p:style>
-      </p:cxnSp>
-      <p:pic>
-        <p:nvPicPr>
-          <p:cNvPr id="26" name="圖片 25"/>
-          <p:cNvPicPr>
-            <a:picLocks noChangeAspect="1"/>
-          </p:cNvPicPr>
-          <p:nvPr/>
-        </p:nvPicPr>
-        <p:blipFill>
-          <a:blip r:embed="rId7">
-            <a:extLst>
-              <a:ext uri="{28A0092B-C50C-407E-A947-70E740481C1C}">
-                <a14:useLocalDpi xmlns:a14="http://schemas.microsoft.com/office/drawing/2010/main" val="0"/>
-              </a:ext>
-            </a:extLst>
-          </a:blip>
-          <a:stretch>
-            <a:fillRect/>
-          </a:stretch>
-        </p:blipFill>
-        <p:spPr>
-          <a:xfrm>
-            <a:off x="5859597" y="485964"/>
-            <a:ext cx="1952907" cy="1773450"/>
-          </a:xfrm>
-          <a:prstGeom prst="rect">
-            <a:avLst/>
-          </a:prstGeom>
-        </p:spPr>
-      </p:pic>
-      <p:pic>
-        <p:nvPicPr>
-          <p:cNvPr id="29" name="圖片 28"/>
-          <p:cNvPicPr>
-            <a:picLocks noChangeAspect="1"/>
-          </p:cNvPicPr>
-          <p:nvPr/>
-        </p:nvPicPr>
-        <p:blipFill>
-          <a:blip r:embed="rId8">
-            <a:extLst>
-              <a:ext uri="{28A0092B-C50C-407E-A947-70E740481C1C}">
-                <a14:useLocalDpi xmlns:a14="http://schemas.microsoft.com/office/drawing/2010/main" val="0"/>
-              </a:ext>
-            </a:extLst>
-          </a:blip>
-          <a:stretch>
-            <a:fillRect/>
-          </a:stretch>
-        </p:blipFill>
-        <p:spPr>
-          <a:xfrm>
-            <a:off x="5626399" y="2601309"/>
-            <a:ext cx="1804764" cy="3743596"/>
-          </a:xfrm>
-          <a:prstGeom prst="rect">
-            <a:avLst/>
-          </a:prstGeom>
-        </p:spPr>
-      </p:pic>
-      <p:sp>
-        <p:nvSpPr>
-          <p:cNvPr id="38" name="矩形 37"/>
-          <p:cNvSpPr/>
-          <p:nvPr/>
-        </p:nvSpPr>
-        <p:spPr>
-          <a:xfrm>
-            <a:off x="207793" y="5063505"/>
-            <a:ext cx="4927784" cy="461665"/>
-          </a:xfrm>
-          <a:prstGeom prst="rect">
-            <a:avLst/>
-          </a:prstGeom>
-        </p:spPr>
-        <p:txBody>
-          <a:bodyPr wrap="square">
-            <a:spAutoFit/>
-          </a:bodyPr>
-          <a:lstStyle/>
-          <a:p>
-            <a:pPr>
-              <a:spcAft>
-                <a:spcPts val="0"/>
-              </a:spcAft>
-            </a:pPr>
-            <a:r>
-              <a:rPr lang="zh-TW" altLang="zh-TW" sz="1200" b="1" kern="100" dirty="0">
-                <a:latin typeface="Calibri" panose="020F0502020204030204" pitchFamily="34" charset="0"/>
-                <a:cs typeface="Times New Roman" panose="02020603050405020304" pitchFamily="18" charset="0"/>
-              </a:rPr>
-              <a:t>管理端頁面：</a:t>
-            </a:r>
-            <a:r>
-              <a:rPr lang="en-US" altLang="zh-TW" sz="1200" b="1" kern="100" dirty="0">
-                <a:latin typeface="Calibri" panose="020F0502020204030204" pitchFamily="34" charset="0"/>
-                <a:cs typeface="Times New Roman" panose="02020603050405020304" pitchFamily="18" charset="0"/>
-              </a:rPr>
-              <a:t> https://my-liff-site.onrender.com/liff-product-admin.html</a:t>
-            </a:r>
-            <a:endParaRPr lang="zh-TW" altLang="zh-TW" sz="1200" kern="100" dirty="0">
-              <a:latin typeface="Calibri" panose="020F0502020204030204" pitchFamily="34" charset="0"/>
-              <a:cs typeface="Times New Roman" panose="02020603050405020304" pitchFamily="18" charset="0"/>
-            </a:endParaRPr>
-          </a:p>
-          <a:p>
-            <a:pPr>
-              <a:spcAft>
-                <a:spcPts val="0"/>
-              </a:spcAft>
-            </a:pPr>
-            <a:r>
-              <a:rPr lang="zh-TW" altLang="zh-TW" sz="1200" b="1" kern="100" dirty="0">
-                <a:latin typeface="Calibri" panose="020F0502020204030204" pitchFamily="34" charset="0"/>
-                <a:cs typeface="Times New Roman" panose="02020603050405020304" pitchFamily="18" charset="0"/>
-              </a:rPr>
-              <a:t>買家端頁面：</a:t>
-            </a:r>
-            <a:r>
-              <a:rPr lang="en-US" altLang="zh-TW" sz="1200" b="1" kern="100" dirty="0">
-                <a:latin typeface="Calibri" panose="020F0502020204030204" pitchFamily="34" charset="0"/>
-                <a:cs typeface="Times New Roman" panose="02020603050405020304" pitchFamily="18" charset="0"/>
-              </a:rPr>
-              <a:t> https://my-liff-site.onrender.com/liff-buyer-orders.html</a:t>
-            </a:r>
-            <a:endParaRPr lang="zh-TW" altLang="zh-TW" sz="1200" kern="100" dirty="0">
-              <a:latin typeface="Calibri" panose="020F0502020204030204" pitchFamily="34" charset="0"/>
-              <a:cs typeface="Times New Roman" panose="02020603050405020304" pitchFamily="18" charset="0"/>
-            </a:endParaRPr>
-          </a:p>
-        </p:txBody>
-      </p:sp>
-      <p:sp>
-        <p:nvSpPr>
-          <p:cNvPr id="41" name="矩形 40"/>
-          <p:cNvSpPr/>
-          <p:nvPr/>
-        </p:nvSpPr>
-        <p:spPr>
-          <a:xfrm>
-            <a:off x="185751" y="4715100"/>
-            <a:ext cx="1107996" cy="369332"/>
-          </a:xfrm>
-          <a:prstGeom prst="rect">
-            <a:avLst/>
-          </a:prstGeom>
-        </p:spPr>
-        <p:txBody>
-          <a:bodyPr wrap="none">
-            <a:spAutoFit/>
-          </a:bodyPr>
-          <a:lstStyle/>
-          <a:p>
-            <a:r>
-              <a:rPr lang="zh-TW" altLang="en-US" b="1" u="sng" dirty="0">
-                <a:solidFill>
-                  <a:srgbClr val="FF0000"/>
-                </a:solidFill>
-              </a:rPr>
-              <a:t>靜態網址</a:t>
-            </a:r>
-          </a:p>
-        </p:txBody>
-      </p:sp>
-      <p:sp>
-        <p:nvSpPr>
-          <p:cNvPr id="42" name="矩形 41"/>
-          <p:cNvSpPr/>
-          <p:nvPr/>
-        </p:nvSpPr>
-        <p:spPr>
-          <a:xfrm>
-            <a:off x="207793" y="5506635"/>
-            <a:ext cx="1683474" cy="369332"/>
-          </a:xfrm>
-          <a:prstGeom prst="rect">
-            <a:avLst/>
-          </a:prstGeom>
-        </p:spPr>
-        <p:txBody>
-          <a:bodyPr wrap="none">
-            <a:spAutoFit/>
-          </a:bodyPr>
-          <a:lstStyle/>
-          <a:p>
-            <a:r>
-              <a:rPr lang="en-US" altLang="zh-TW" b="1" u="sng" dirty="0">
-                <a:solidFill>
-                  <a:srgbClr val="FF0000"/>
-                </a:solidFill>
-                <a:latin typeface="-apple-system"/>
-              </a:rPr>
-              <a:t>Public repository</a:t>
-            </a:r>
-            <a:endParaRPr lang="zh-TW" altLang="en-US" b="1" u="sng" dirty="0">
-              <a:solidFill>
-                <a:srgbClr val="FF0000"/>
-              </a:solidFill>
-            </a:endParaRPr>
-          </a:p>
-        </p:txBody>
-      </p:sp>
-      <p:sp>
-        <p:nvSpPr>
-          <p:cNvPr id="43" name="矩形 42"/>
-          <p:cNvSpPr/>
-          <p:nvPr/>
-        </p:nvSpPr>
-        <p:spPr>
-          <a:xfrm>
-            <a:off x="278665" y="5947373"/>
-            <a:ext cx="1699440" cy="646331"/>
-          </a:xfrm>
-          <a:prstGeom prst="rect">
-            <a:avLst/>
-          </a:prstGeom>
-        </p:spPr>
-        <p:txBody>
-          <a:bodyPr wrap="none">
-            <a:spAutoFit/>
-          </a:bodyPr>
-          <a:lstStyle/>
-          <a:p>
-            <a:r>
-              <a:rPr lang="en-US" altLang="zh-TW" sz="1200" b="1" kern="100" dirty="0" smtClean="0">
-                <a:solidFill>
-                  <a:prstClr val="black"/>
-                </a:solidFill>
-                <a:latin typeface="Calibri" panose="020F0502020204030204" pitchFamily="34" charset="0"/>
-                <a:cs typeface="Times New Roman" panose="02020603050405020304" pitchFamily="18" charset="0"/>
-              </a:rPr>
-              <a:t>liff-buyer-orders.html</a:t>
-            </a:r>
-          </a:p>
-          <a:p>
-            <a:pPr lvl="0"/>
-            <a:r>
-              <a:rPr lang="en-US" altLang="zh-TW" sz="1200" b="1" kern="100" dirty="0" smtClean="0">
-                <a:solidFill>
-                  <a:prstClr val="black"/>
-                </a:solidFill>
-                <a:latin typeface="Calibri" panose="020F0502020204030204" pitchFamily="34" charset="0"/>
-                <a:cs typeface="Times New Roman" panose="02020603050405020304" pitchFamily="18" charset="0"/>
-              </a:rPr>
-              <a:t>liff-product-admin.html</a:t>
-            </a:r>
-            <a:endParaRPr lang="en-US" altLang="zh-TW" sz="1200" b="1" kern="100" dirty="0">
-              <a:solidFill>
-                <a:prstClr val="black"/>
-              </a:solidFill>
-              <a:latin typeface="Calibri" panose="020F0502020204030204" pitchFamily="34" charset="0"/>
-              <a:cs typeface="Times New Roman" panose="02020603050405020304" pitchFamily="18" charset="0"/>
-            </a:endParaRPr>
-          </a:p>
-          <a:p>
-            <a:pPr lvl="0"/>
-            <a:r>
-              <a:rPr lang="en-US" altLang="zh-TW" sz="1200" b="1" kern="100" dirty="0" smtClean="0">
-                <a:solidFill>
-                  <a:prstClr val="black"/>
-                </a:solidFill>
-                <a:latin typeface="Calibri" panose="020F0502020204030204" pitchFamily="34" charset="0"/>
-                <a:cs typeface="Times New Roman" panose="02020603050405020304" pitchFamily="18" charset="0"/>
-              </a:rPr>
-              <a:t>liff-shipping.html</a:t>
-            </a:r>
-            <a:endParaRPr lang="en-US" altLang="zh-TW" sz="1200" b="1" kern="100" dirty="0">
-              <a:solidFill>
-                <a:prstClr val="black"/>
-              </a:solidFill>
-              <a:latin typeface="Calibri" panose="020F0502020204030204" pitchFamily="34" charset="0"/>
-              <a:cs typeface="Times New Roman" panose="02020603050405020304" pitchFamily="18" charset="0"/>
-            </a:endParaRPr>
-          </a:p>
-        </p:txBody>
-      </p:sp>
-      <p:sp>
-        <p:nvSpPr>
-          <p:cNvPr id="44" name="矩形 43"/>
-          <p:cNvSpPr/>
-          <p:nvPr/>
-        </p:nvSpPr>
-        <p:spPr>
-          <a:xfrm>
-            <a:off x="120920" y="4715100"/>
-            <a:ext cx="5014657" cy="810070"/>
-          </a:xfrm>
-          <a:prstGeom prst="rect">
-            <a:avLst/>
-          </a:prstGeom>
-          <a:noFill/>
-        </p:spPr>
-        <p:style>
-          <a:lnRef idx="2">
-            <a:schemeClr val="accent1">
-              <a:shade val="50000"/>
-            </a:schemeClr>
-          </a:lnRef>
-          <a:fillRef idx="1">
-            <a:schemeClr val="accent1"/>
-          </a:fillRef>
-          <a:effectRef idx="0">
-            <a:schemeClr val="accent1"/>
-          </a:effectRef>
-          <a:fontRef idx="minor">
-            <a:schemeClr val="lt1"/>
-          </a:fontRef>
-        </p:style>
-        <p:txBody>
-          <a:bodyPr rtlCol="0" anchor="ctr"/>
-          <a:lstStyle/>
-          <a:p>
-            <a:pPr algn="ctr"/>
-            <a:endParaRPr lang="zh-TW" altLang="en-US"/>
-          </a:p>
-        </p:txBody>
-      </p:sp>
-      <p:sp>
-        <p:nvSpPr>
-          <p:cNvPr id="45" name="矩形 44"/>
-          <p:cNvSpPr/>
-          <p:nvPr/>
-        </p:nvSpPr>
-        <p:spPr>
-          <a:xfrm>
-            <a:off x="104942" y="5584864"/>
-            <a:ext cx="1873163" cy="1008840"/>
-          </a:xfrm>
-          <a:prstGeom prst="rect">
-            <a:avLst/>
-          </a:prstGeom>
-          <a:noFill/>
-        </p:spPr>
-        <p:style>
-          <a:lnRef idx="2">
-            <a:schemeClr val="accent1">
-              <a:shade val="50000"/>
-            </a:schemeClr>
-          </a:lnRef>
-          <a:fillRef idx="1">
-            <a:schemeClr val="accent1"/>
-          </a:fillRef>
-          <a:effectRef idx="0">
-            <a:schemeClr val="accent1"/>
-          </a:effectRef>
-          <a:fontRef idx="minor">
-            <a:schemeClr val="lt1"/>
-          </a:fontRef>
-        </p:style>
-        <p:txBody>
-          <a:bodyPr rtlCol="0" anchor="ctr"/>
-          <a:lstStyle/>
-          <a:p>
-            <a:pPr algn="ctr"/>
-            <a:endParaRPr lang="zh-TW" altLang="en-US"/>
-          </a:p>
-        </p:txBody>
-      </p:sp>
-    </p:spTree>
-    <p:extLst>
-      <p:ext uri="{BB962C8B-B14F-4D97-AF65-F5344CB8AC3E}">
-        <p14:creationId xmlns:p14="http://schemas.microsoft.com/office/powerpoint/2010/main" val="2933569209"/>
-      </p:ext>
-    </p:extLst>
-  </p:cSld>
-  <p:clrMapOvr>
-    <a:masterClrMapping/>
-  </p:clrMapOvr>
-</p:sld>
-</file>
-
-<file path=ppt/slides/slide5.xml><?xml version="1.0" encoding="utf-8"?>
-<p:sld xmlns:a="http://schemas.openxmlformats.org/drawingml/2006/main" xmlns:r="http://schemas.openxmlformats.org/officeDocument/2006/relationships" xmlns:p="http://schemas.openxmlformats.org/presentationml/2006/main">
-  <p:cSld>
-    <p:spTree>
-      <p:nvGrpSpPr>
-        <p:cNvPr id="1" name=""/>
-        <p:cNvGrpSpPr/>
-        <p:nvPr/>
-      </p:nvGrpSpPr>
-      <p:grpSpPr>
-        <a:xfrm>
-          <a:off x="0" y="0"/>
-          <a:ext cx="0" cy="0"/>
-          <a:chOff x="0" y="0"/>
-          <a:chExt cx="0" cy="0"/>
-        </a:xfrm>
-      </p:grpSpPr>
-      <p:pic>
-        <p:nvPicPr>
-          <p:cNvPr id="4" name="圖片 3"/>
-          <p:cNvPicPr>
-            <a:picLocks noChangeAspect="1"/>
-          </p:cNvPicPr>
-          <p:nvPr/>
-        </p:nvPicPr>
         <p:blipFill rotWithShape="1">
           <a:blip r:embed="rId2">
             <a:extLst>
@@ -4855,7 +4053,7 @@
 </p:sld>
 </file>
 
-<file path=ppt/slides/slide6.xml><?xml version="1.0" encoding="utf-8"?>
+<file path=ppt/slides/slide5.xml><?xml version="1.0" encoding="utf-8"?>
 <p:sld xmlns:a="http://schemas.openxmlformats.org/drawingml/2006/main" xmlns:r="http://schemas.openxmlformats.org/officeDocument/2006/relationships" xmlns:p="http://schemas.openxmlformats.org/presentationml/2006/main">
   <p:cSld>
     <p:spTree>
@@ -5048,7 +4246,7 @@
 </p:sld>
 </file>
 
-<file path=ppt/slides/slide7.xml><?xml version="1.0" encoding="utf-8"?>
+<file path=ppt/slides/slide6.xml><?xml version="1.0" encoding="utf-8"?>
 <p:sld xmlns:a="http://schemas.openxmlformats.org/drawingml/2006/main" xmlns:r="http://schemas.openxmlformats.org/officeDocument/2006/relationships" xmlns:p="http://schemas.openxmlformats.org/presentationml/2006/main">
   <p:cSld>
     <p:spTree>
@@ -5521,6 +4719,96 @@
     <p:extLst>
       <p:ext uri="{BB962C8B-B14F-4D97-AF65-F5344CB8AC3E}">
         <p14:creationId xmlns:p14="http://schemas.microsoft.com/office/powerpoint/2010/main" val="2702851738"/>
+      </p:ext>
+    </p:extLst>
+  </p:cSld>
+  <p:clrMapOvr>
+    <a:masterClrMapping/>
+  </p:clrMapOvr>
+</p:sld>
+</file>
+
+<file path=ppt/slides/slide7.xml><?xml version="1.0" encoding="utf-8"?>
+<p:sld xmlns:a="http://schemas.openxmlformats.org/drawingml/2006/main" xmlns:r="http://schemas.openxmlformats.org/officeDocument/2006/relationships" xmlns:p="http://schemas.openxmlformats.org/presentationml/2006/main">
+  <p:cSld>
+    <p:spTree>
+      <p:nvGrpSpPr>
+        <p:cNvPr id="1" name=""/>
+        <p:cNvGrpSpPr/>
+        <p:nvPr/>
+      </p:nvGrpSpPr>
+      <p:grpSpPr>
+        <a:xfrm>
+          <a:off x="0" y="0"/>
+          <a:ext cx="0" cy="0"/>
+          <a:chOff x="0" y="0"/>
+          <a:chExt cx="0" cy="0"/>
+        </a:xfrm>
+      </p:grpSpPr>
+      <p:pic>
+        <p:nvPicPr>
+          <p:cNvPr id="4" name="圖片 3"/>
+          <p:cNvPicPr>
+            <a:picLocks noChangeAspect="1"/>
+          </p:cNvPicPr>
+          <p:nvPr/>
+        </p:nvPicPr>
+        <p:blipFill>
+          <a:blip r:embed="rId2">
+            <a:extLst>
+              <a:ext uri="{28A0092B-C50C-407E-A947-70E740481C1C}">
+                <a14:useLocalDpi xmlns:a14="http://schemas.microsoft.com/office/drawing/2010/main" val="0"/>
+              </a:ext>
+            </a:extLst>
+          </a:blip>
+          <a:stretch>
+            <a:fillRect/>
+          </a:stretch>
+        </p:blipFill>
+        <p:spPr>
+          <a:xfrm>
+            <a:off x="4424827" y="0"/>
+            <a:ext cx="4719173" cy="5125414"/>
+          </a:xfrm>
+          <a:prstGeom prst="rect">
+            <a:avLst/>
+          </a:prstGeom>
+        </p:spPr>
+      </p:pic>
+      <p:pic>
+        <p:nvPicPr>
+          <p:cNvPr id="5" name="圖片 4"/>
+          <p:cNvPicPr>
+            <a:picLocks noChangeAspect="1"/>
+          </p:cNvPicPr>
+          <p:nvPr/>
+        </p:nvPicPr>
+        <p:blipFill>
+          <a:blip r:embed="rId3">
+            <a:extLst>
+              <a:ext uri="{28A0092B-C50C-407E-A947-70E740481C1C}">
+                <a14:useLocalDpi xmlns:a14="http://schemas.microsoft.com/office/drawing/2010/main" val="0"/>
+              </a:ext>
+            </a:extLst>
+          </a:blip>
+          <a:stretch>
+            <a:fillRect/>
+          </a:stretch>
+        </p:blipFill>
+        <p:spPr>
+          <a:xfrm>
+            <a:off x="-108519" y="1"/>
+            <a:ext cx="4748432" cy="5157192"/>
+          </a:xfrm>
+          <a:prstGeom prst="rect">
+            <a:avLst/>
+          </a:prstGeom>
+        </p:spPr>
+      </p:pic>
+    </p:spTree>
+    <p:extLst>
+      <p:ext uri="{BB962C8B-B14F-4D97-AF65-F5344CB8AC3E}">
+        <p14:creationId xmlns:p14="http://schemas.microsoft.com/office/powerpoint/2010/main" val="578561926"/>
       </p:ext>
     </p:extLst>
   </p:cSld>

</xml_diff>